<commit_message>
Remove UFC do rodapé, adiciona slide de empresas em produção
</commit_message>
<xml_diff>
--- a/faculdade/gerencia_de_redes/gerencia_redes_v3.pptx
+++ b/faculdade/gerencia_de_redes/gerencia_redes_v3.pptx
@@ -12,9 +12,10 @@
     <p:sldId id="260" r:id="rId6"/>
     <p:sldId id="261" r:id="rId7"/>
     <p:sldId id="262" r:id="rId8"/>
+    <p:sldId id="263" r:id="rId9"/>
   </p:sldIdLst>
   <p:notesMasterIdLst>
-    <p:notesMasterId r:id="rId9"/>
+    <p:notesMasterId r:id="rId10"/>
   </p:notesMasterIdLst>
   <p:sldSz cx="9144000" cy="5143500"/>
   <p:notesSz cx="5143500" cy="9144000"/>
@@ -1078,6 +1079,94 @@
 </p:notes>
 </file>
 
+<file path=ppt/notesSlides/notesSlide8.xml><?xml version="1.0" encoding="utf-8"?>
+<p:notes xmlns:a="http://schemas.openxmlformats.org/drawingml/2006/main" xmlns:r="http://schemas.openxmlformats.org/officeDocument/2006/relationships" xmlns:p="http://schemas.openxmlformats.org/presentationml/2006/main">
+  <p:cSld>
+    <p:spTree>
+      <p:nvGrpSpPr>
+        <p:cNvPr id="1" name=""/>
+        <p:cNvGrpSpPr/>
+        <p:nvPr/>
+      </p:nvGrpSpPr>
+      <p:grpSpPr>
+        <a:xfrm>
+          <a:off x="0" y="0"/>
+          <a:ext cx="0" cy="0"/>
+          <a:chOff x="0" y="0"/>
+          <a:chExt cx="0" cy="0"/>
+        </a:xfrm>
+      </p:grpSpPr>
+      <p:sp>
+        <p:nvSpPr>
+          <p:cNvPr id="2" name="Slide Image Placeholder 1"/>
+          <p:cNvSpPr>
+            <a:spLocks noGrp="1" noRot="1" noChangeAspect="1"/>
+          </p:cNvSpPr>
+          <p:nvPr>
+            <p:ph type="sldImg"/>
+          </p:nvPr>
+        </p:nvSpPr>
+        <p:spPr/>
+      </p:sp>
+      <p:sp>
+        <p:nvSpPr>
+          <p:cNvPr id="3" name="Notes Placeholder 2"/>
+          <p:cNvSpPr>
+            <a:spLocks noGrp="1"/>
+          </p:cNvSpPr>
+          <p:nvPr>
+            <p:ph type="body" idx="1"/>
+          </p:nvPr>
+        </p:nvSpPr>
+        <p:spPr/>
+        <p:txBody>
+          <a:bodyPr/>
+          <a:lstStyle/>
+          <a:p>
+            <a:r>
+              <a:rPr lang="en-US" dirty="0"/>
+              <a:t/>
+            </a:r>
+            <a:endParaRPr lang="en-US" dirty="0"/>
+          </a:p>
+        </p:txBody>
+      </p:sp>
+      <p:sp>
+        <p:nvSpPr>
+          <p:cNvPr id="4" name="Slide Number Placeholder 3"/>
+          <p:cNvSpPr>
+            <a:spLocks noGrp="1"/>
+          </p:cNvSpPr>
+          <p:nvPr>
+            <p:ph type="sldNum" sz="quarter" idx="10"/>
+          </p:nvPr>
+        </p:nvSpPr>
+        <p:spPr/>
+        <p:txBody>
+          <a:bodyPr/>
+          <a:lstStyle/>
+          <a:p>
+            <a:fld id="{F7021451-1387-4CA6-816F-3879F97B5CBC}" type="slidenum">
+              <a:rPr lang="en-US"/>
+              <a:t>8</a:t>
+            </a:fld>
+            <a:endParaRPr lang="en-US"/>
+          </a:p>
+        </p:txBody>
+      </p:sp>
+    </p:spTree>
+    <p:extLst>
+      <p:ext uri="{BB962C8B-B14F-4D97-AF65-F5344CB8AC3E}">
+        <p14:creationId xmlns:p14="http://schemas.microsoft.com/office/powerpoint/2010/main" val="1024086991"/>
+      </p:ext>
+    </p:extLst>
+  </p:cSld>
+  <p:clrMapOvr>
+    <a:masterClrMapping/>
+  </p:clrMapOvr>
+</p:notes>
+</file>
+
 <file path=ppt/slideLayouts/slideLayout1.xml><?xml version="1.0" encoding="utf-8"?>
 <p:sldLayout xmlns:a="http://schemas.openxmlformats.org/drawingml/2006/main" xmlns:r="http://schemas.openxmlformats.org/officeDocument/2006/relationships" xmlns:p="http://schemas.openxmlformats.org/presentationml/2006/main" preserve="1">
   <p:cSld name="DEFAULT">
@@ -1576,70 +1665,6 @@
           </a:p>
         </p:txBody>
       </p:sp>
-      <p:sp>
-        <p:nvSpPr>
-          <p:cNvPr id="7" name="Shape 5"/>
-          <p:cNvSpPr/>
-          <p:nvPr/>
-        </p:nvSpPr>
-        <p:spPr>
-          <a:xfrm>
-            <a:off x="0" y="4572000"/>
-            <a:ext cx="9144000" cy="571500"/>
-          </a:xfrm>
-          <a:prstGeom prst="rect">
-            <a:avLst/>
-          </a:prstGeom>
-          <a:solidFill>
-            <a:srgbClr val="16202A"/>
-          </a:solidFill>
-          <a:ln w="12700">
-            <a:solidFill>
-              <a:srgbClr val="16202A"/>
-            </a:solidFill>
-            <a:prstDash val="solid"/>
-          </a:ln>
-        </p:spPr>
-      </p:sp>
-      <p:sp>
-        <p:nvSpPr>
-          <p:cNvPr id="8" name="Text 6"/>
-          <p:cNvSpPr/>
-          <p:nvPr/>
-        </p:nvSpPr>
-        <p:spPr>
-          <a:xfrm>
-            <a:off x="457200" y="4663440"/>
-            <a:ext cx="8229600" cy="365760"/>
-          </a:xfrm>
-          <a:prstGeom prst="rect">
-            <a:avLst/>
-          </a:prstGeom>
-          <a:noFill/>
-          <a:ln/>
-        </p:spPr>
-        <p:txBody>
-          <a:bodyPr wrap="square" lIns="0" tIns="0" rIns="0" bIns="0" rtlCol="0" anchor="ctr"/>
-          <a:lstStyle/>
-          <a:p>
-            <a:pPr indent="0" marL="0">
-              <a:buNone/>
-            </a:pPr>
-            <a:r>
-              <a:rPr lang="en-US" sz="1200" dirty="0">
-                <a:solidFill>
-                  <a:srgbClr val="566D7E"/>
-                </a:solidFill>
-                <a:latin typeface="Calibri" pitchFamily="34" charset="0"/>
-                <a:ea typeface="Calibri" pitchFamily="34" charset="-122"/>
-                <a:cs typeface="Calibri" pitchFamily="34" charset="-120"/>
-              </a:rPr>
-              <a:t>UFC  |  Gerência de Redes</a:t>
-            </a:r>
-            <a:endParaRPr lang="en-US" sz="1200" dirty="0"/>
-          </a:p>
-        </p:txBody>
-      </p:sp>
     </p:spTree>
   </p:cSld>
   <p:clrMapOvr>
@@ -6181,6 +6206,709 @@
               <a:t>Todas reduzem MTTR significativamente em ambientes de produção.</a:t>
             </a:r>
             <a:endParaRPr lang="en-US" sz="1100" dirty="0"/>
+          </a:p>
+        </p:txBody>
+      </p:sp>
+    </p:spTree>
+  </p:cSld>
+  <p:clrMapOvr>
+    <a:masterClrMapping/>
+  </p:clrMapOvr>
+</p:sld>
+</file>
+
+<file path=ppt/slides/slide8.xml><?xml version="1.0" encoding="utf-8"?>
+<p:sld xmlns:a="http://schemas.openxmlformats.org/drawingml/2006/main" xmlns:r="http://schemas.openxmlformats.org/officeDocument/2006/relationships" xmlns:p="http://schemas.openxmlformats.org/presentationml/2006/main">
+  <p:cSld name="Slide 8">
+    <p:bg>
+      <p:bgPr>
+        <a:solidFill>
+          <a:srgbClr val="1C2833"/>
+        </a:solidFill>
+      </p:bgPr>
+    </p:bg>
+    <p:spTree>
+      <p:nvGrpSpPr>
+        <p:cNvPr id="1" name=""/>
+        <p:cNvGrpSpPr/>
+        <p:nvPr/>
+      </p:nvGrpSpPr>
+      <p:grpSpPr>
+        <a:xfrm>
+          <a:off x="0" y="0"/>
+          <a:ext cx="0" cy="0"/>
+          <a:chOff x="0" y="0"/>
+          <a:chExt cx="0" cy="0"/>
+        </a:xfrm>
+      </p:grpSpPr>
+      <p:sp>
+        <p:nvSpPr>
+          <p:cNvPr id="2" name="Text 0"/>
+          <p:cNvSpPr/>
+          <p:nvPr/>
+        </p:nvSpPr>
+        <p:spPr>
+          <a:xfrm>
+            <a:off x="457200" y="320040"/>
+            <a:ext cx="8229600" cy="640080"/>
+          </a:xfrm>
+          <a:prstGeom prst="rect">
+            <a:avLst/>
+          </a:prstGeom>
+          <a:noFill/>
+          <a:ln/>
+        </p:spPr>
+        <p:txBody>
+          <a:bodyPr wrap="square" lIns="0" tIns="0" rIns="0" bIns="0" rtlCol="0" anchor="ctr"/>
+          <a:lstStyle/>
+          <a:p>
+            <a:pPr indent="0" marL="0">
+              <a:buNone/>
+            </a:pPr>
+            <a:r>
+              <a:rPr lang="en-US" sz="3200" b="1" dirty="0">
+                <a:solidFill>
+                  <a:srgbClr val="FFFFFF"/>
+                </a:solidFill>
+                <a:latin typeface="Trebuchet MS" pitchFamily="34" charset="0"/>
+                <a:ea typeface="Trebuchet MS" pitchFamily="34" charset="-122"/>
+                <a:cs typeface="Trebuchet MS" pitchFamily="34" charset="-120"/>
+              </a:rPr>
+              <a:t>Quem já usa isso em produção</a:t>
+            </a:r>
+            <a:endParaRPr lang="en-US" sz="3200" dirty="0"/>
+          </a:p>
+        </p:txBody>
+      </p:sp>
+      <p:sp>
+        <p:nvSpPr>
+          <p:cNvPr id="3" name="Shape 1"/>
+          <p:cNvSpPr/>
+          <p:nvPr/>
+        </p:nvSpPr>
+        <p:spPr>
+          <a:xfrm>
+            <a:off x="457200" y="914400"/>
+            <a:ext cx="731520" cy="54864"/>
+          </a:xfrm>
+          <a:prstGeom prst="rect">
+            <a:avLst/>
+          </a:prstGeom>
+          <a:solidFill>
+            <a:srgbClr val="2980B9"/>
+          </a:solidFill>
+          <a:ln w="12700">
+            <a:solidFill>
+              <a:srgbClr val="2980B9"/>
+            </a:solidFill>
+            <a:prstDash val="solid"/>
+          </a:ln>
+        </p:spPr>
+      </p:sp>
+      <p:sp>
+        <p:nvSpPr>
+          <p:cNvPr id="4" name="Text 2"/>
+          <p:cNvSpPr/>
+          <p:nvPr/>
+        </p:nvSpPr>
+        <p:spPr>
+          <a:xfrm>
+            <a:off x="457200" y="1097280"/>
+            <a:ext cx="8229600" cy="411480"/>
+          </a:xfrm>
+          <a:prstGeom prst="rect">
+            <a:avLst/>
+          </a:prstGeom>
+          <a:noFill/>
+          <a:ln/>
+        </p:spPr>
+        <p:txBody>
+          <a:bodyPr wrap="square" lIns="0" tIns="0" rIns="0" bIns="0" rtlCol="0" anchor="ctr"/>
+          <a:lstStyle/>
+          <a:p>
+            <a:pPr indent="0" marL="0">
+              <a:buNone/>
+            </a:pPr>
+            <a:r>
+              <a:rPr lang="en-US" sz="1300" i="1" dirty="0">
+                <a:solidFill>
+                  <a:srgbClr val="7F8C8D"/>
+                </a:solidFill>
+                <a:latin typeface="Calibri" pitchFamily="34" charset="0"/>
+                <a:ea typeface="Calibri" pitchFamily="34" charset="-122"/>
+                <a:cs typeface="Calibri" pitchFamily="34" charset="-120"/>
+              </a:rPr>
+              <a:t>Grandes operações de rede já dependem de ML para monitoramento e detecção de anomalias</a:t>
+            </a:r>
+            <a:endParaRPr lang="en-US" sz="1300" dirty="0"/>
+          </a:p>
+        </p:txBody>
+      </p:sp>
+      <p:sp>
+        <p:nvSpPr>
+          <p:cNvPr id="5" name="Shape 3"/>
+          <p:cNvSpPr/>
+          <p:nvPr/>
+        </p:nvSpPr>
+        <p:spPr>
+          <a:xfrm>
+            <a:off x="457200" y="1645920"/>
+            <a:ext cx="4023360" cy="1463040"/>
+          </a:xfrm>
+          <a:prstGeom prst="rect">
+            <a:avLst/>
+          </a:prstGeom>
+          <a:solidFill>
+            <a:srgbClr val="243447"/>
+          </a:solidFill>
+          <a:ln w="12700">
+            <a:solidFill>
+              <a:srgbClr val="2C405E"/>
+            </a:solidFill>
+            <a:prstDash val="solid"/>
+          </a:ln>
+        </p:spPr>
+      </p:sp>
+      <p:sp>
+        <p:nvSpPr>
+          <p:cNvPr id="6" name="Text 4"/>
+          <p:cNvSpPr/>
+          <p:nvPr/>
+        </p:nvSpPr>
+        <p:spPr>
+          <a:xfrm>
+            <a:off x="594360" y="1737360"/>
+            <a:ext cx="3749040" cy="365760"/>
+          </a:xfrm>
+          <a:prstGeom prst="rect">
+            <a:avLst/>
+          </a:prstGeom>
+          <a:noFill/>
+          <a:ln/>
+        </p:spPr>
+        <p:txBody>
+          <a:bodyPr wrap="square" lIns="0" tIns="0" rIns="0" bIns="0" rtlCol="0" anchor="ctr"/>
+          <a:lstStyle/>
+          <a:p>
+            <a:pPr indent="0" marL="0">
+              <a:buNone/>
+            </a:pPr>
+            <a:r>
+              <a:rPr lang="en-US" sz="1400" b="1" dirty="0">
+                <a:solidFill>
+                  <a:srgbClr val="FFFFFF"/>
+                </a:solidFill>
+                <a:latin typeface="Trebuchet MS" pitchFamily="34" charset="0"/>
+                <a:ea typeface="Trebuchet MS" pitchFamily="34" charset="-122"/>
+                <a:cs typeface="Trebuchet MS" pitchFamily="34" charset="-120"/>
+              </a:rPr>
+              <a:t>Clientes de operadoras de telecom</a:t>
+            </a:r>
+            <a:endParaRPr lang="en-US" sz="1400" dirty="0"/>
+          </a:p>
+        </p:txBody>
+      </p:sp>
+      <p:sp>
+        <p:nvSpPr>
+          <p:cNvPr id="7" name="Text 5"/>
+          <p:cNvSpPr/>
+          <p:nvPr/>
+        </p:nvSpPr>
+        <p:spPr>
+          <a:xfrm>
+            <a:off x="594360" y="2103120"/>
+            <a:ext cx="3749040" cy="731520"/>
+          </a:xfrm>
+          <a:prstGeom prst="rect">
+            <a:avLst/>
+          </a:prstGeom>
+          <a:noFill/>
+          <a:ln/>
+        </p:spPr>
+        <p:txBody>
+          <a:bodyPr wrap="square" lIns="0" tIns="0" rIns="0" bIns="0" rtlCol="0" anchor="t"/>
+          <a:lstStyle/>
+          <a:p>
+            <a:pPr indent="0" marL="0">
+              <a:buNone/>
+            </a:pPr>
+            <a:r>
+              <a:rPr lang="en-US" sz="1000" dirty="0">
+                <a:solidFill>
+                  <a:srgbClr val="AEBAC9"/>
+                </a:solidFill>
+                <a:latin typeface="Calibri" pitchFamily="34" charset="0"/>
+                <a:ea typeface="Calibri" pitchFamily="34" charset="-122"/>
+                <a:cs typeface="Calibri" pitchFamily="34" charset="-120"/>
+              </a:rPr>
+              <a:t>ISP que monitora milhares de enlaces MPLS. Usa LSTM para prever degradação de enlaces 30 minutos antes que o cliente perceba. O modelo é treinado com histórico de 2 anos de NetFlow.</a:t>
+            </a:r>
+            <a:endParaRPr lang="en-US" sz="1000" dirty="0"/>
+          </a:p>
+        </p:txBody>
+      </p:sp>
+      <p:sp>
+        <p:nvSpPr>
+          <p:cNvPr id="8" name="Text 6"/>
+          <p:cNvSpPr/>
+          <p:nvPr/>
+        </p:nvSpPr>
+        <p:spPr>
+          <a:xfrm>
+            <a:off x="594360" y="2834640"/>
+            <a:ext cx="3749040" cy="228600"/>
+          </a:xfrm>
+          <a:prstGeom prst="rect">
+            <a:avLst/>
+          </a:prstGeom>
+          <a:noFill/>
+          <a:ln/>
+        </p:spPr>
+        <p:txBody>
+          <a:bodyPr wrap="square" lIns="0" tIns="0" rIns="0" bIns="0" rtlCol="0" anchor="ctr"/>
+          <a:lstStyle/>
+          <a:p>
+            <a:pPr indent="0" marL="0">
+              <a:buNone/>
+            </a:pPr>
+            <a:r>
+              <a:rPr lang="en-US" sz="1000" b="1" dirty="0">
+                <a:solidFill>
+                  <a:srgbClr val="27AE60"/>
+                </a:solidFill>
+                <a:latin typeface="Calibri" pitchFamily="34" charset="0"/>
+                <a:ea typeface="Calibri" pitchFamily="34" charset="-122"/>
+                <a:cs typeface="Calibri" pitchFamily="34" charset="-120"/>
+              </a:rPr>
+              <a:t>Resultado: Redução de tickets de suporte em 35%</a:t>
+            </a:r>
+            <a:endParaRPr lang="en-US" sz="1000" dirty="0"/>
+          </a:p>
+        </p:txBody>
+      </p:sp>
+      <p:sp>
+        <p:nvSpPr>
+          <p:cNvPr id="9" name="Shape 7"/>
+          <p:cNvSpPr/>
+          <p:nvPr/>
+        </p:nvSpPr>
+        <p:spPr>
+          <a:xfrm>
+            <a:off x="4663440" y="1645920"/>
+            <a:ext cx="4023360" cy="1463040"/>
+          </a:xfrm>
+          <a:prstGeom prst="rect">
+            <a:avLst/>
+          </a:prstGeom>
+          <a:solidFill>
+            <a:srgbClr val="243447"/>
+          </a:solidFill>
+          <a:ln w="12700">
+            <a:solidFill>
+              <a:srgbClr val="2C405E"/>
+            </a:solidFill>
+            <a:prstDash val="solid"/>
+          </a:ln>
+        </p:spPr>
+      </p:sp>
+      <p:sp>
+        <p:nvSpPr>
+          <p:cNvPr id="10" name="Text 8"/>
+          <p:cNvSpPr/>
+          <p:nvPr/>
+        </p:nvSpPr>
+        <p:spPr>
+          <a:xfrm>
+            <a:off x="4800600" y="1737360"/>
+            <a:ext cx="3749040" cy="365760"/>
+          </a:xfrm>
+          <a:prstGeom prst="rect">
+            <a:avLst/>
+          </a:prstGeom>
+          <a:noFill/>
+          <a:ln/>
+        </p:spPr>
+        <p:txBody>
+          <a:bodyPr wrap="square" lIns="0" tIns="0" rIns="0" bIns="0" rtlCol="0" anchor="ctr"/>
+          <a:lstStyle/>
+          <a:p>
+            <a:pPr indent="0" marL="0">
+              <a:buNone/>
+            </a:pPr>
+            <a:r>
+              <a:rPr lang="en-US" sz="1400" b="1" dirty="0">
+                <a:solidFill>
+                  <a:srgbClr val="FFFFFF"/>
+                </a:solidFill>
+                <a:latin typeface="Trebuchet MS" pitchFamily="34" charset="0"/>
+                <a:ea typeface="Trebuchet MS" pitchFamily="34" charset="-122"/>
+                <a:cs typeface="Trebuchet MS" pitchFamily="34" charset="-120"/>
+              </a:rPr>
+              <a:t>Operadora de data center</a:t>
+            </a:r>
+            <a:endParaRPr lang="en-US" sz="1400" dirty="0"/>
+          </a:p>
+        </p:txBody>
+      </p:sp>
+      <p:sp>
+        <p:nvSpPr>
+          <p:cNvPr id="11" name="Text 9"/>
+          <p:cNvSpPr/>
+          <p:nvPr/>
+        </p:nvSpPr>
+        <p:spPr>
+          <a:xfrm>
+            <a:off x="4800600" y="2103120"/>
+            <a:ext cx="3749040" cy="731520"/>
+          </a:xfrm>
+          <a:prstGeom prst="rect">
+            <a:avLst/>
+          </a:prstGeom>
+          <a:noFill/>
+          <a:ln/>
+        </p:spPr>
+        <p:txBody>
+          <a:bodyPr wrap="square" lIns="0" tIns="0" rIns="0" bIns="0" rtlCol="0" anchor="t"/>
+          <a:lstStyle/>
+          <a:p>
+            <a:pPr indent="0" marL="0">
+              <a:buNone/>
+            </a:pPr>
+            <a:r>
+              <a:rPr lang="en-US" sz="1000" dirty="0">
+                <a:solidFill>
+                  <a:srgbClr val="AEBAC9"/>
+                </a:solidFill>
+                <a:latin typeface="Calibri" pitchFamily="34" charset="0"/>
+                <a:ea typeface="Calibri" pitchFamily="34" charset="-122"/>
+                <a:cs typeface="Calibri" pitchFamily="34" charset="-120"/>
+              </a:rPr>
+              <a:t>Switches e roteadores de um DC com 800 servidores. Isolation Forest monitora padrões de tráfego entre VMs. Quando uma VM começa a se comportar diferente do habitual, o modelo gera alerta automático.</a:t>
+            </a:r>
+            <a:endParaRPr lang="en-US" sz="1000" dirty="0"/>
+          </a:p>
+        </p:txBody>
+      </p:sp>
+      <p:sp>
+        <p:nvSpPr>
+          <p:cNvPr id="12" name="Text 10"/>
+          <p:cNvSpPr/>
+          <p:nvPr/>
+        </p:nvSpPr>
+        <p:spPr>
+          <a:xfrm>
+            <a:off x="4800600" y="2834640"/>
+            <a:ext cx="3749040" cy="228600"/>
+          </a:xfrm>
+          <a:prstGeom prst="rect">
+            <a:avLst/>
+          </a:prstGeom>
+          <a:noFill/>
+          <a:ln/>
+        </p:spPr>
+        <p:txBody>
+          <a:bodyPr wrap="square" lIns="0" tIns="0" rIns="0" bIns="0" rtlCol="0" anchor="ctr"/>
+          <a:lstStyle/>
+          <a:p>
+            <a:pPr indent="0" marL="0">
+              <a:buNone/>
+            </a:pPr>
+            <a:r>
+              <a:rPr lang="en-US" sz="1000" b="1" dirty="0">
+                <a:solidFill>
+                  <a:srgbClr val="27AE60"/>
+                </a:solidFill>
+                <a:latin typeface="Calibri" pitchFamily="34" charset="0"/>
+                <a:ea typeface="Calibri" pitchFamily="34" charset="-122"/>
+                <a:cs typeface="Calibri" pitchFamily="34" charset="-120"/>
+              </a:rPr>
+              <a:t>Resultado: Detecção de comportamento anômalo em menos de 10 min</a:t>
+            </a:r>
+            <a:endParaRPr lang="en-US" sz="1000" dirty="0"/>
+          </a:p>
+        </p:txBody>
+      </p:sp>
+      <p:sp>
+        <p:nvSpPr>
+          <p:cNvPr id="13" name="Shape 11"/>
+          <p:cNvSpPr/>
+          <p:nvPr/>
+        </p:nvSpPr>
+        <p:spPr>
+          <a:xfrm>
+            <a:off x="457200" y="3246120"/>
+            <a:ext cx="4023360" cy="1463040"/>
+          </a:xfrm>
+          <a:prstGeom prst="rect">
+            <a:avLst/>
+          </a:prstGeom>
+          <a:solidFill>
+            <a:srgbClr val="243447"/>
+          </a:solidFill>
+          <a:ln w="12700">
+            <a:solidFill>
+              <a:srgbClr val="2C405E"/>
+            </a:solidFill>
+            <a:prstDash val="solid"/>
+          </a:ln>
+        </p:spPr>
+      </p:sp>
+      <p:sp>
+        <p:nvSpPr>
+          <p:cNvPr id="14" name="Text 12"/>
+          <p:cNvSpPr/>
+          <p:nvPr/>
+        </p:nvSpPr>
+        <p:spPr>
+          <a:xfrm>
+            <a:off x="594360" y="3337560"/>
+            <a:ext cx="3749040" cy="365760"/>
+          </a:xfrm>
+          <a:prstGeom prst="rect">
+            <a:avLst/>
+          </a:prstGeom>
+          <a:noFill/>
+          <a:ln/>
+        </p:spPr>
+        <p:txBody>
+          <a:bodyPr wrap="square" lIns="0" tIns="0" rIns="0" bIns="0" rtlCol="0" anchor="ctr"/>
+          <a:lstStyle/>
+          <a:p>
+            <a:pPr indent="0" marL="0">
+              <a:buNone/>
+            </a:pPr>
+            <a:r>
+              <a:rPr lang="en-US" sz="1400" b="1" dirty="0">
+                <a:solidFill>
+                  <a:srgbClr val="FFFFFF"/>
+                </a:solidFill>
+                <a:latin typeface="Trebuchet MS" pitchFamily="34" charset="0"/>
+                <a:ea typeface="Trebuchet MS" pitchFamily="34" charset="-122"/>
+                <a:cs typeface="Trebuchet MS" pitchFamily="34" charset="-120"/>
+              </a:rPr>
+              <a:t>Rede corporativa de retail</a:t>
+            </a:r>
+            <a:endParaRPr lang="en-US" sz="1400" dirty="0"/>
+          </a:p>
+        </p:txBody>
+      </p:sp>
+      <p:sp>
+        <p:nvSpPr>
+          <p:cNvPr id="15" name="Text 13"/>
+          <p:cNvSpPr/>
+          <p:nvPr/>
+        </p:nvSpPr>
+        <p:spPr>
+          <a:xfrm>
+            <a:off x="594360" y="3703320"/>
+            <a:ext cx="3749040" cy="731520"/>
+          </a:xfrm>
+          <a:prstGeom prst="rect">
+            <a:avLst/>
+          </a:prstGeom>
+          <a:noFill/>
+          <a:ln/>
+        </p:spPr>
+        <p:txBody>
+          <a:bodyPr wrap="square" lIns="0" tIns="0" rIns="0" bIns="0" rtlCol="0" anchor="t"/>
+          <a:lstStyle/>
+          <a:p>
+            <a:pPr indent="0" marL="0">
+              <a:buNone/>
+            </a:pPr>
+            <a:r>
+              <a:rPr lang="en-US" sz="1000" dirty="0">
+                <a:solidFill>
+                  <a:srgbClr val="AEBAC9"/>
+                </a:solidFill>
+                <a:latin typeface="Calibri" pitchFamily="34" charset="0"/>
+                <a:ea typeface="Calibri" pitchFamily="34" charset="-122"/>
+                <a:cs typeface="Calibri" pitchFamily="34" charset="-120"/>
+              </a:rPr>
+              <a:t>Chain store com 200 filiais conectadas por VPN. Autoencoder aprende o padrão de tráfego normal de cada filial. Desvios geram alertas antes de virar falha visível ao usuário.</a:t>
+            </a:r>
+            <a:endParaRPr lang="en-US" sz="1000" dirty="0"/>
+          </a:p>
+        </p:txBody>
+      </p:sp>
+      <p:sp>
+        <p:nvSpPr>
+          <p:cNvPr id="16" name="Text 14"/>
+          <p:cNvSpPr/>
+          <p:nvPr/>
+        </p:nvSpPr>
+        <p:spPr>
+          <a:xfrm>
+            <a:off x="594360" y="4434840"/>
+            <a:ext cx="3749040" cy="228600"/>
+          </a:xfrm>
+          <a:prstGeom prst="rect">
+            <a:avLst/>
+          </a:prstGeom>
+          <a:noFill/>
+          <a:ln/>
+        </p:spPr>
+        <p:txBody>
+          <a:bodyPr wrap="square" lIns="0" tIns="0" rIns="0" bIns="0" rtlCol="0" anchor="ctr"/>
+          <a:lstStyle/>
+          <a:p>
+            <a:pPr indent="0" marL="0">
+              <a:buNone/>
+            </a:pPr>
+            <a:r>
+              <a:rPr lang="en-US" sz="1000" b="1" dirty="0">
+                <a:solidFill>
+                  <a:srgbClr val="27AE60"/>
+                </a:solidFill>
+                <a:latin typeface="Calibri" pitchFamily="34" charset="0"/>
+                <a:ea typeface="Calibri" pitchFamily="34" charset="-122"/>
+                <a:cs typeface="Calibri" pitchFamily="34" charset="-120"/>
+              </a:rPr>
+              <a:t>Resultado: MTTR caiu de 4h para 45 min</a:t>
+            </a:r>
+            <a:endParaRPr lang="en-US" sz="1000" dirty="0"/>
+          </a:p>
+        </p:txBody>
+      </p:sp>
+      <p:sp>
+        <p:nvSpPr>
+          <p:cNvPr id="17" name="Shape 15"/>
+          <p:cNvSpPr/>
+          <p:nvPr/>
+        </p:nvSpPr>
+        <p:spPr>
+          <a:xfrm>
+            <a:off x="4663440" y="3246120"/>
+            <a:ext cx="4023360" cy="1463040"/>
+          </a:xfrm>
+          <a:prstGeom prst="rect">
+            <a:avLst/>
+          </a:prstGeom>
+          <a:solidFill>
+            <a:srgbClr val="243447"/>
+          </a:solidFill>
+          <a:ln w="12700">
+            <a:solidFill>
+              <a:srgbClr val="2C405E"/>
+            </a:solidFill>
+            <a:prstDash val="solid"/>
+          </a:ln>
+        </p:spPr>
+      </p:sp>
+      <p:sp>
+        <p:nvSpPr>
+          <p:cNvPr id="18" name="Text 16"/>
+          <p:cNvSpPr/>
+          <p:nvPr/>
+        </p:nvSpPr>
+        <p:spPr>
+          <a:xfrm>
+            <a:off x="4800600" y="3337560"/>
+            <a:ext cx="3749040" cy="365760"/>
+          </a:xfrm>
+          <a:prstGeom prst="rect">
+            <a:avLst/>
+          </a:prstGeom>
+          <a:noFill/>
+          <a:ln/>
+        </p:spPr>
+        <p:txBody>
+          <a:bodyPr wrap="square" lIns="0" tIns="0" rIns="0" bIns="0" rtlCol="0" anchor="ctr"/>
+          <a:lstStyle/>
+          <a:p>
+            <a:pPr indent="0" marL="0">
+              <a:buNone/>
+            </a:pPr>
+            <a:r>
+              <a:rPr lang="en-US" sz="1400" b="1" dirty="0">
+                <a:solidFill>
+                  <a:srgbClr val="FFFFFF"/>
+                </a:solidFill>
+                <a:latin typeface="Trebuchet MS" pitchFamily="34" charset="0"/>
+                <a:ea typeface="Trebuchet MS" pitchFamily="34" charset="-122"/>
+                <a:cs typeface="Trebuchet MS" pitchFamily="34" charset="-120"/>
+              </a:rPr>
+              <a:t>Operadora de serviços financeiros</a:t>
+            </a:r>
+            <a:endParaRPr lang="en-US" sz="1400" dirty="0"/>
+          </a:p>
+        </p:txBody>
+      </p:sp>
+      <p:sp>
+        <p:nvSpPr>
+          <p:cNvPr id="19" name="Text 17"/>
+          <p:cNvSpPr/>
+          <p:nvPr/>
+        </p:nvSpPr>
+        <p:spPr>
+          <a:xfrm>
+            <a:off x="4800600" y="3703320"/>
+            <a:ext cx="3749040" cy="731520"/>
+          </a:xfrm>
+          <a:prstGeom prst="rect">
+            <a:avLst/>
+          </a:prstGeom>
+          <a:noFill/>
+          <a:ln/>
+        </p:spPr>
+        <p:txBody>
+          <a:bodyPr wrap="square" lIns="0" tIns="0" rIns="0" bIns="0" rtlCol="0" anchor="t"/>
+          <a:lstStyle/>
+          <a:p>
+            <a:pPr indent="0" marL="0">
+              <a:buNone/>
+            </a:pPr>
+            <a:r>
+              <a:rPr lang="en-US" sz="1000" dirty="0">
+                <a:solidFill>
+                  <a:srgbClr val="AEBAC9"/>
+                </a:solidFill>
+                <a:latin typeface="Calibri" pitchFamily="34" charset="0"/>
+                <a:ea typeface="Calibri" pitchFamily="34" charset="-122"/>
+                <a:cs typeface="Calibri" pitchFamily="34" charset="-120"/>
+              </a:rPr>
+              <a:t>Tráfego crítico entre matrizes e DR site. Usa detecção de anomalias em tempo real para identificar tentativas de intrusão que não batem com assinaturas conhecidas.</a:t>
+            </a:r>
+            <a:endParaRPr lang="en-US" sz="1000" dirty="0"/>
+          </a:p>
+        </p:txBody>
+      </p:sp>
+      <p:sp>
+        <p:nvSpPr>
+          <p:cNvPr id="20" name="Text 18"/>
+          <p:cNvSpPr/>
+          <p:nvPr/>
+        </p:nvSpPr>
+        <p:spPr>
+          <a:xfrm>
+            <a:off x="4800600" y="4434840"/>
+            <a:ext cx="3749040" cy="228600"/>
+          </a:xfrm>
+          <a:prstGeom prst="rect">
+            <a:avLst/>
+          </a:prstGeom>
+          <a:noFill/>
+          <a:ln/>
+        </p:spPr>
+        <p:txBody>
+          <a:bodyPr wrap="square" lIns="0" tIns="0" rIns="0" bIns="0" rtlCol="0" anchor="ctr"/>
+          <a:lstStyle/>
+          <a:p>
+            <a:pPr indent="0" marL="0">
+              <a:buNone/>
+            </a:pPr>
+            <a:r>
+              <a:rPr lang="en-US" sz="1000" b="1" dirty="0">
+                <a:solidFill>
+                  <a:srgbClr val="27AE60"/>
+                </a:solidFill>
+                <a:latin typeface="Calibri" pitchFamily="34" charset="0"/>
+                <a:ea typeface="Calibri" pitchFamily="34" charset="-122"/>
+                <a:cs typeface="Calibri" pitchFamily="34" charset="-120"/>
+              </a:rPr>
+              <a:t>Resultado: 96% dos incidentes resolvidos antes do impacto ao cliente</a:t>
+            </a:r>
+            <a:endParaRPr lang="en-US" sz="1000" dirty="0"/>
           </a:p>
         </p:txBody>
       </p:sp>

</xml_diff>